<commit_message>
feat: ML+DL+GradCAM 통합 파이프라인 — Streamlit CSV Grad-CAM + PPT 슬라이드 + Word 부록K 추가
</commit_message>
<xml_diff>
--- a/Homework/DL_FactoryAutomation/산출물/딥러닝_FEMTO_RUL_발표자료_v2.pptx
+++ b/Homework/DL_FactoryAutomation/산출물/딥러닝_FEMTO_RUL_발표자료_v2.pptx
@@ -17,6 +17,7 @@
     <p:sldId id="264" r:id="rId10"/>
     <p:sldId id="265" r:id="rId11"/>
     <p:sldId id="266" r:id="rId12"/>
+    <p:sldId id="268" r:id="rId19"/>
   </p:sldIdLst>
   <p:notesMasterIdLst>
     <p:notesMasterId r:id="rId13"/>
@@ -7085,6 +7086,716 @@
 </p:sld>
 </file>
 
+<file path=ppt/slides/slide13.xml><?xml version="1.0" encoding="utf-8"?>
+<p:sld xmlns:a="http://schemas.openxmlformats.org/drawingml/2006/main" xmlns:p="http://schemas.openxmlformats.org/presentationml/2006/main" xmlns:r="http://schemas.openxmlformats.org/officeDocument/2006/relationships">
+  <p:cSld>
+    <p:spTree>
+      <p:sp>
+        <p:nvSpPr>
+          <p:cNvPr id="1" name="TextBox 0"/>
+          <p:cNvSpPr txBox="1"/>
+          <p:nvPr/>
+        </p:nvSpPr>
+        <p:spPr>
+          <a:xfrm>
+            <a:off x="274320" y="274320"/>
+            <a:ext cx="11643360" cy="640080"/>
+          </a:xfrm>
+          <a:prstGeom prst="rect">
+            <a:avLst/>
+          </a:prstGeom>
+          <a:noFill/>
+        </p:spPr>
+        <p:txBody>
+          <a:bodyPr wrap="square">
+            <a:spAutoFit/>
+          </a:bodyPr>
+          <a:lstStyle/>
+          <a:p>
+            <a:pPr algn="ctr"/>
+            <a:r>
+              <a:rPr sz="2400" b="1">
+                <a:solidFill>
+                  <a:srgbClr val="1A4A7A"/>
+                </a:solidFill>
+              </a:rPr>
+              <a:t>ML + DL + Grad-CAM 통합 진단 파이프라인</a:t>
+            </a:r>
+          </a:p>
+        </p:txBody>
+      </p:sp>
+      <p:sp>
+        <p:nvSpPr>
+          <p:cNvPr id="2" name="TextBox 1"/>
+          <p:cNvSpPr txBox="1"/>
+          <p:nvPr/>
+        </p:nvSpPr>
+        <p:spPr>
+          <a:xfrm>
+            <a:off x="274320" y="868680"/>
+            <a:ext cx="11643360" cy="365760"/>
+          </a:xfrm>
+          <a:prstGeom prst="rect">
+            <a:avLst/>
+          </a:prstGeom>
+          <a:noFill/>
+        </p:spPr>
+        <p:txBody>
+          <a:bodyPr wrap="square">
+            <a:spAutoFit/>
+          </a:bodyPr>
+          <a:lstStyle/>
+          <a:p>
+            <a:pPr algn="ctr"/>
+            <a:r>
+              <a:rPr sz="1300" b="0">
+                <a:solidFill>
+                  <a:srgbClr val="555555"/>
+                </a:solidFill>
+              </a:rPr>
+              <a:t>FEMTO-ST 베어링 이상탐지 · RUL 예측 · 고장 시각화 3단계 완성</a:t>
+            </a:r>
+          </a:p>
+        </p:txBody>
+      </p:sp>
+      <p:sp>
+        <p:nvSpPr>
+          <p:cNvPr id="99" name="rect"/>
+          <p:cNvSpPr/>
+          <p:nvPr/>
+        </p:nvSpPr>
+        <p:spPr>
+          <a:xfrm>
+            <a:off x="274320" y="1325880"/>
+            <a:ext cx="3698240" cy="457200"/>
+          </a:xfrm>
+          <a:prstGeom prst="rect">
+            <a:avLst/>
+          </a:prstGeom>
+          <a:solidFill>
+            <a:srgbClr val="1A4A7A"/>
+          </a:solidFill>
+        </p:spPr>
+        <p:txBody/>
+      </p:sp>
+      <p:sp>
+        <p:nvSpPr>
+          <p:cNvPr id="100" name="TextBox 99"/>
+          <p:cNvSpPr txBox="1"/>
+          <p:nvPr/>
+        </p:nvSpPr>
+        <p:spPr>
+          <a:xfrm>
+            <a:off x="274320" y="1325880"/>
+            <a:ext cx="3698240" cy="457200"/>
+          </a:xfrm>
+          <a:prstGeom prst="rect">
+            <a:avLst/>
+          </a:prstGeom>
+          <a:noFill/>
+        </p:spPr>
+        <p:txBody>
+          <a:bodyPr wrap="square">
+            <a:spAutoFit/>
+          </a:bodyPr>
+          <a:lstStyle/>
+          <a:p>
+            <a:pPr algn="ctr"/>
+            <a:r>
+              <a:rPr sz="1400" b="1">
+                <a:solidFill>
+                  <a:srgbClr val="FFFFFF"/>
+                </a:solidFill>
+              </a:rPr>
+              <a:t>① ML 단계</a:t>
+            </a:r>
+          </a:p>
+        </p:txBody>
+      </p:sp>
+      <p:sp>
+        <p:nvSpPr>
+          <p:cNvPr id="99" name="rect"/>
+          <p:cNvSpPr/>
+          <p:nvPr/>
+        </p:nvSpPr>
+        <p:spPr>
+          <a:xfrm>
+            <a:off x="274320" y="1783080"/>
+            <a:ext cx="3698240" cy="411480"/>
+          </a:xfrm>
+          <a:prstGeom prst="rect">
+            <a:avLst/>
+          </a:prstGeom>
+          <a:solidFill>
+            <a:srgbClr val="1A4A7A"/>
+          </a:solidFill>
+        </p:spPr>
+        <p:txBody/>
+      </p:sp>
+      <p:sp>
+        <p:nvSpPr>
+          <p:cNvPr id="101" name="TextBox 100"/>
+          <p:cNvSpPr txBox="1"/>
+          <p:nvPr/>
+        </p:nvSpPr>
+        <p:spPr>
+          <a:xfrm>
+            <a:off x="274320" y="1783080"/>
+            <a:ext cx="3698240" cy="411480"/>
+          </a:xfrm>
+          <a:prstGeom prst="rect">
+            <a:avLst/>
+          </a:prstGeom>
+          <a:noFill/>
+        </p:spPr>
+        <p:txBody>
+          <a:bodyPr wrap="square">
+            <a:spAutoFit/>
+          </a:bodyPr>
+          <a:lstStyle/>
+          <a:p>
+            <a:pPr algn="ctr"/>
+            <a:r>
+              <a:rPr sz="1200" b="1">
+                <a:solidFill>
+                  <a:srgbClr val="FFFFFF"/>
+                </a:solidFill>
+              </a:rPr>
+              <a:t>정상 / 열화 분류</a:t>
+            </a:r>
+          </a:p>
+        </p:txBody>
+      </p:sp>
+      <p:sp>
+        <p:nvSpPr>
+          <p:cNvPr id="99" name="rect"/>
+          <p:cNvSpPr/>
+          <p:nvPr/>
+        </p:nvSpPr>
+        <p:spPr>
+          <a:xfrm>
+            <a:off x="274320" y="2194560"/>
+            <a:ext cx="3698240" cy="3337560"/>
+          </a:xfrm>
+          <a:prstGeom prst="rect">
+            <a:avLst/>
+          </a:prstGeom>
+          <a:solidFill>
+            <a:srgbClr val="E8F0FE"/>
+          </a:solidFill>
+        </p:spPr>
+        <p:txBody/>
+      </p:sp>
+      <p:sp>
+        <p:nvSpPr>
+          <p:cNvPr id="102" name="TextBox 101"/>
+          <p:cNvSpPr txBox="1"/>
+          <p:nvPr/>
+        </p:nvSpPr>
+        <p:spPr>
+          <a:xfrm>
+            <a:off x="347472" y="2240280"/>
+            <a:ext cx="3588512" cy="3200400"/>
+          </a:xfrm>
+          <a:prstGeom prst="rect">
+            <a:avLst/>
+          </a:prstGeom>
+          <a:noFill/>
+        </p:spPr>
+        <p:txBody>
+          <a:bodyPr wrap="square">
+            <a:spAutoFit/>
+          </a:bodyPr>
+          <a:lstStyle/>
+          <a:p>
+            <a:pPr algn="l"/>
+            <a:r>
+              <a:rPr sz="1100" b="0">
+                <a:solidFill>
+                  <a:srgbClr val="222222"/>
+                </a:solidFill>
+              </a:rPr>
+              <a:t>▸ 알고리즘: RandomForest · XGBoost</a:t>
+            </a:r>
+          </a:p>
+          <a:p>
+            <a:pPr algn="l"/>
+            <a:r>
+              <a:rPr sz="1100" b="0">
+                <a:solidFill>
+                  <a:srgbClr val="222222"/>
+                </a:solidFill>
+              </a:rPr>
+              <a:t>▸ 입력: 진동 RMS · 첨도 · 크레스트 인자</a:t>
+            </a:r>
+          </a:p>
+          <a:p>
+            <a:pPr algn="l"/>
+            <a:r>
+              <a:rPr sz="1100" b="0">
+                <a:solidFill>
+                  <a:srgbClr val="222222"/>
+                </a:solidFill>
+              </a:rPr>
+              <a:t>▸ 출력: 열화 확률(%) · 임계값 기반 판정</a:t>
+            </a:r>
+          </a:p>
+          <a:p>
+            <a:pPr algn="l"/>
+            <a:r>
+              <a:rPr sz="1100" b="0">
+                <a:solidFill>
+                  <a:srgbClr val="222222"/>
+                </a:solidFill>
+              </a:rPr>
+              <a:t>▸ 역할: '지금 이상이 있는가?' 1차 경보</a:t>
+            </a:r>
+          </a:p>
+        </p:txBody>
+      </p:sp>
+      <p:sp>
+        <p:nvSpPr>
+          <p:cNvPr id="99" name="rect"/>
+          <p:cNvSpPr/>
+          <p:nvPr/>
+        </p:nvSpPr>
+        <p:spPr>
+          <a:xfrm>
+            <a:off x="4246880" y="1325880"/>
+            <a:ext cx="3698240" cy="457200"/>
+          </a:xfrm>
+          <a:prstGeom prst="rect">
+            <a:avLst/>
+          </a:prstGeom>
+          <a:solidFill>
+            <a:srgbClr val="0A6A2A"/>
+          </a:solidFill>
+        </p:spPr>
+        <p:txBody/>
+      </p:sp>
+      <p:sp>
+        <p:nvSpPr>
+          <p:cNvPr id="103" name="TextBox 102"/>
+          <p:cNvSpPr txBox="1"/>
+          <p:nvPr/>
+        </p:nvSpPr>
+        <p:spPr>
+          <a:xfrm>
+            <a:off x="4246880" y="1325880"/>
+            <a:ext cx="3698240" cy="457200"/>
+          </a:xfrm>
+          <a:prstGeom prst="rect">
+            <a:avLst/>
+          </a:prstGeom>
+          <a:noFill/>
+        </p:spPr>
+        <p:txBody>
+          <a:bodyPr wrap="square">
+            <a:spAutoFit/>
+          </a:bodyPr>
+          <a:lstStyle/>
+          <a:p>
+            <a:pPr algn="ctr"/>
+            <a:r>
+              <a:rPr sz="1400" b="1">
+                <a:solidFill>
+                  <a:srgbClr val="FFFFFF"/>
+                </a:solidFill>
+              </a:rPr>
+              <a:t>② DL 단계</a:t>
+            </a:r>
+          </a:p>
+        </p:txBody>
+      </p:sp>
+      <p:sp>
+        <p:nvSpPr>
+          <p:cNvPr id="99" name="rect"/>
+          <p:cNvSpPr/>
+          <p:nvPr/>
+        </p:nvSpPr>
+        <p:spPr>
+          <a:xfrm>
+            <a:off x="4246880" y="1783080"/>
+            <a:ext cx="3698240" cy="411480"/>
+          </a:xfrm>
+          <a:prstGeom prst="rect">
+            <a:avLst/>
+          </a:prstGeom>
+          <a:solidFill>
+            <a:srgbClr val="0A6A2A"/>
+          </a:solidFill>
+        </p:spPr>
+        <p:txBody/>
+      </p:sp>
+      <p:sp>
+        <p:nvSpPr>
+          <p:cNvPr id="104" name="TextBox 103"/>
+          <p:cNvSpPr txBox="1"/>
+          <p:nvPr/>
+        </p:nvSpPr>
+        <p:spPr>
+          <a:xfrm>
+            <a:off x="4246880" y="1783080"/>
+            <a:ext cx="3698240" cy="411480"/>
+          </a:xfrm>
+          <a:prstGeom prst="rect">
+            <a:avLst/>
+          </a:prstGeom>
+          <a:noFill/>
+        </p:spPr>
+        <p:txBody>
+          <a:bodyPr wrap="square">
+            <a:spAutoFit/>
+          </a:bodyPr>
+          <a:lstStyle/>
+          <a:p>
+            <a:pPr algn="ctr"/>
+            <a:r>
+              <a:rPr sz="1200" b="1">
+                <a:solidFill>
+                  <a:srgbClr val="FFFFFF"/>
+                </a:solidFill>
+              </a:rPr>
+              <a:t>잔여수명(RUL) 정밀 예측</a:t>
+            </a:r>
+          </a:p>
+        </p:txBody>
+      </p:sp>
+      <p:sp>
+        <p:nvSpPr>
+          <p:cNvPr id="99" name="rect"/>
+          <p:cNvSpPr/>
+          <p:nvPr/>
+        </p:nvSpPr>
+        <p:spPr>
+          <a:xfrm>
+            <a:off x="4246880" y="2194560"/>
+            <a:ext cx="3698240" cy="3337560"/>
+          </a:xfrm>
+          <a:prstGeom prst="rect">
+            <a:avLst/>
+          </a:prstGeom>
+          <a:solidFill>
+            <a:srgbClr val="E6F7E9"/>
+          </a:solidFill>
+        </p:spPr>
+        <p:txBody/>
+      </p:sp>
+      <p:sp>
+        <p:nvSpPr>
+          <p:cNvPr id="105" name="TextBox 104"/>
+          <p:cNvSpPr txBox="1"/>
+          <p:nvPr/>
+        </p:nvSpPr>
+        <p:spPr>
+          <a:xfrm>
+            <a:off x="4320032" y="2240280"/>
+            <a:ext cx="3588512" cy="3200400"/>
+          </a:xfrm>
+          <a:prstGeom prst="rect">
+            <a:avLst/>
+          </a:prstGeom>
+          <a:noFill/>
+        </p:spPr>
+        <p:txBody>
+          <a:bodyPr wrap="square">
+            <a:spAutoFit/>
+          </a:bodyPr>
+          <a:lstStyle/>
+          <a:p>
+            <a:pPr algn="l"/>
+            <a:r>
+              <a:rPr sz="1100" b="0">
+                <a:solidFill>
+                  <a:srgbClr val="222222"/>
+                </a:solidFill>
+              </a:rPr>
+              <a:t>▸ 알고리즘: GRU v2 (Batch Norm + Layer Norm)</a:t>
+            </a:r>
+          </a:p>
+          <a:p>
+            <a:pPr algn="l"/>
+            <a:r>
+              <a:rPr sz="1100" b="0">
+                <a:solidFill>
+                  <a:srgbClr val="222222"/>
+                </a:solidFill>
+              </a:rPr>
+              <a:t>▸ 입력: 진동 시계열 시퀀스</a:t>
+            </a:r>
+          </a:p>
+          <a:p>
+            <a:pPr algn="l"/>
+            <a:r>
+              <a:rPr sz="1100" b="0">
+                <a:solidFill>
+                  <a:srgbClr val="222222"/>
+                </a:solidFill>
+              </a:rPr>
+              <a:t>▸ 출력: 잔여 가동 시간(분) 예측값</a:t>
+            </a:r>
+          </a:p>
+          <a:p>
+            <a:pPr algn="l"/>
+            <a:r>
+              <a:rPr sz="1100" b="0">
+                <a:solidFill>
+                  <a:srgbClr val="222222"/>
+                </a:solidFill>
+              </a:rPr>
+              <a:t>▸ 역할: '언제 교체해야 하는가?' 정밀 예측</a:t>
+            </a:r>
+          </a:p>
+        </p:txBody>
+      </p:sp>
+      <p:sp>
+        <p:nvSpPr>
+          <p:cNvPr id="99" name="rect"/>
+          <p:cNvSpPr/>
+          <p:nvPr/>
+        </p:nvSpPr>
+        <p:spPr>
+          <a:xfrm>
+            <a:off x="8219440" y="1325880"/>
+            <a:ext cx="3698240" cy="457200"/>
+          </a:xfrm>
+          <a:prstGeom prst="rect">
+            <a:avLst/>
+          </a:prstGeom>
+          <a:solidFill>
+            <a:srgbClr val="8B0000"/>
+          </a:solidFill>
+        </p:spPr>
+        <p:txBody/>
+      </p:sp>
+      <p:sp>
+        <p:nvSpPr>
+          <p:cNvPr id="106" name="TextBox 105"/>
+          <p:cNvSpPr txBox="1"/>
+          <p:nvPr/>
+        </p:nvSpPr>
+        <p:spPr>
+          <a:xfrm>
+            <a:off x="8219440" y="1325880"/>
+            <a:ext cx="3698240" cy="457200"/>
+          </a:xfrm>
+          <a:prstGeom prst="rect">
+            <a:avLst/>
+          </a:prstGeom>
+          <a:noFill/>
+        </p:spPr>
+        <p:txBody>
+          <a:bodyPr wrap="square">
+            <a:spAutoFit/>
+          </a:bodyPr>
+          <a:lstStyle/>
+          <a:p>
+            <a:pPr algn="ctr"/>
+            <a:r>
+              <a:rPr sz="1400" b="1">
+                <a:solidFill>
+                  <a:srgbClr val="FFFFFF"/>
+                </a:solidFill>
+              </a:rPr>
+              <a:t>③ CNN + Grad-CAM</a:t>
+            </a:r>
+          </a:p>
+        </p:txBody>
+      </p:sp>
+      <p:sp>
+        <p:nvSpPr>
+          <p:cNvPr id="99" name="rect"/>
+          <p:cNvSpPr/>
+          <p:nvPr/>
+        </p:nvSpPr>
+        <p:spPr>
+          <a:xfrm>
+            <a:off x="8219440" y="1783080"/>
+            <a:ext cx="3698240" cy="411480"/>
+          </a:xfrm>
+          <a:prstGeom prst="rect">
+            <a:avLst/>
+          </a:prstGeom>
+          <a:solidFill>
+            <a:srgbClr val="8B0000"/>
+          </a:solidFill>
+        </p:spPr>
+        <p:txBody/>
+      </p:sp>
+      <p:sp>
+        <p:nvSpPr>
+          <p:cNvPr id="107" name="TextBox 106"/>
+          <p:cNvSpPr txBox="1"/>
+          <p:nvPr/>
+        </p:nvSpPr>
+        <p:spPr>
+          <a:xfrm>
+            <a:off x="8219440" y="1783080"/>
+            <a:ext cx="3698240" cy="411480"/>
+          </a:xfrm>
+          <a:prstGeom prst="rect">
+            <a:avLst/>
+          </a:prstGeom>
+          <a:noFill/>
+        </p:spPr>
+        <p:txBody>
+          <a:bodyPr wrap="square">
+            <a:spAutoFit/>
+          </a:bodyPr>
+          <a:lstStyle/>
+          <a:p>
+            <a:pPr algn="ctr"/>
+            <a:r>
+              <a:rPr sz="1200" b="1">
+                <a:solidFill>
+                  <a:srgbClr val="FFFFFF"/>
+                </a:solidFill>
+              </a:rPr>
+              <a:t>고장 부위·시점 시각화</a:t>
+            </a:r>
+          </a:p>
+        </p:txBody>
+      </p:sp>
+      <p:sp>
+        <p:nvSpPr>
+          <p:cNvPr id="99" name="rect"/>
+          <p:cNvSpPr/>
+          <p:nvPr/>
+        </p:nvSpPr>
+        <p:spPr>
+          <a:xfrm>
+            <a:off x="8219440" y="2194560"/>
+            <a:ext cx="3698240" cy="3337560"/>
+          </a:xfrm>
+          <a:prstGeom prst="rect">
+            <a:avLst/>
+          </a:prstGeom>
+          <a:solidFill>
+            <a:srgbClr val="FDEDED"/>
+          </a:solidFill>
+        </p:spPr>
+        <p:txBody/>
+      </p:sp>
+      <p:sp>
+        <p:nvSpPr>
+          <p:cNvPr id="108" name="TextBox 107"/>
+          <p:cNvSpPr txBox="1"/>
+          <p:nvPr/>
+        </p:nvSpPr>
+        <p:spPr>
+          <a:xfrm>
+            <a:off x="8292592" y="2240280"/>
+            <a:ext cx="3588512" cy="3200400"/>
+          </a:xfrm>
+          <a:prstGeom prst="rect">
+            <a:avLst/>
+          </a:prstGeom>
+          <a:noFill/>
+        </p:spPr>
+        <p:txBody>
+          <a:bodyPr wrap="square">
+            <a:spAutoFit/>
+          </a:bodyPr>
+          <a:lstStyle/>
+          <a:p>
+            <a:pPr algn="l"/>
+            <a:r>
+              <a:rPr sz="1100" b="0">
+                <a:solidFill>
+                  <a:srgbClr val="222222"/>
+                </a:solidFill>
+              </a:rPr>
+              <a:t>▸ 알고리즘: CNN (Conv2D × 3 레이어)</a:t>
+            </a:r>
+          </a:p>
+          <a:p>
+            <a:pPr algn="l"/>
+            <a:r>
+              <a:rPr sz="1100" b="0">
+                <a:solidFill>
+                  <a:srgbClr val="222222"/>
+                </a:solidFill>
+              </a:rPr>
+              <a:t>▸ 입력: 진동 신호 → matplotlib 이미지 변환</a:t>
+            </a:r>
+          </a:p>
+          <a:p>
+            <a:pPr algn="l"/>
+            <a:r>
+              <a:rPr sz="1100" b="0">
+                <a:solidFill>
+                  <a:srgbClr val="222222"/>
+                </a:solidFill>
+              </a:rPr>
+              <a:t>▸ Grad-CAM: 마지막 Conv 기울기 역전파</a:t>
+            </a:r>
+          </a:p>
+          <a:p>
+            <a:pPr algn="l"/>
+            <a:r>
+              <a:rPr sz="1100" b="0">
+                <a:solidFill>
+                  <a:srgbClr val="222222"/>
+                </a:solidFill>
+              </a:rPr>
+              <a:t>  → 히트맵으로 '어느 시점이 위험했나' 표시</a:t>
+            </a:r>
+          </a:p>
+          <a:p>
+            <a:pPr algn="l"/>
+            <a:r>
+              <a:rPr sz="1100" b="0">
+                <a:solidFill>
+                  <a:srgbClr val="222222"/>
+                </a:solidFill>
+              </a:rPr>
+              <a:t>▸ 역할: XAI — CNN 판정 근거 시각화</a:t>
+            </a:r>
+          </a:p>
+        </p:txBody>
+      </p:sp>
+      <p:sp>
+        <p:nvSpPr>
+          <p:cNvPr id="109" name="TextBox 108"/>
+          <p:cNvSpPr txBox="1"/>
+          <p:nvPr/>
+        </p:nvSpPr>
+        <p:spPr>
+          <a:xfrm>
+            <a:off x="274320" y="5669280"/>
+            <a:ext cx="11643360" cy="411480"/>
+          </a:xfrm>
+          <a:prstGeom prst="rect">
+            <a:avLst/>
+          </a:prstGeom>
+          <a:noFill/>
+        </p:spPr>
+        <p:txBody>
+          <a:bodyPr wrap="square">
+            <a:spAutoFit/>
+          </a:bodyPr>
+          <a:lstStyle/>
+          <a:p>
+            <a:pPr algn="ctr"/>
+            <a:r>
+              <a:rPr sz="1200" b="1">
+                <a:solidFill>
+                  <a:srgbClr val="333333"/>
+                </a:solidFill>
+              </a:rPr>
+              <a:t>① ML 이상 탐지   →   ② DL 잔여수명 예측   →   ③ CNN + Grad-CAM 시각화   →   정비 의사결정 지원</a:t>
+            </a:r>
+          </a:p>
+        </p:txBody>
+      </p:sp>
+    </p:spTree>
+  </p:cSld>
+  <p:clrMapOvr>
+    <a:masterClrMapping/>
+  </p:clrMapOvr>
+</p:sld>
+</file>
+
 <file path=ppt/slides/slide2.xml><?xml version="1.0" encoding="utf-8"?>
 <p:sld xmlns:a="http://schemas.openxmlformats.org/drawingml/2006/main" xmlns:r="http://schemas.openxmlformats.org/officeDocument/2006/relationships" xmlns:p="http://schemas.openxmlformats.org/presentationml/2006/main">
   <p:cSld name="Slide 2">

</xml_diff>